<commit_message>
Align Topic 2.5 with OCR J277 and restore the standard experience player
Replace assembly-instruction enrichment with language-choice content, focus IDE activities on specified facilities, and rebuild matching worksheets and lesson slides. Use the established panorama renderer and verify scoring, saved progress and review mode.
</commit_message>
<xml_diff>
--- a/presentations/PL_L01_LanguageLevelLab_Lesson.pptx
+++ b/presentations/PL_L01_LanguageLevelLab_Lesson.pptx
@@ -2,30 +2,30 @@
 <file path=ppt/presentation.xml><?xml version="1.0" encoding="utf-8"?>
 <p:presentation xmlns:p="http://schemas.openxmlformats.org/presentationml/2006/main">
   <p:sldMasterIdLst>
-    <p:sldMasterId xmlns:r="http://schemas.openxmlformats.org/officeDocument/2006/relationships" id="2147483648" r:id="Rfec8d5dc40e64179"/>
+    <p:sldMasterId xmlns:r="http://schemas.openxmlformats.org/officeDocument/2006/relationships" id="2147483648" r:id="R09049fe9ce574066"/>
   </p:sldMasterIdLst>
   <p:notesMasterIdLst>
-    <p:notesMasterId xmlns:r="http://schemas.openxmlformats.org/officeDocument/2006/relationships" r:id="Refbb7c5e3dc7430e"/>
+    <p:notesMasterId xmlns:r="http://schemas.openxmlformats.org/officeDocument/2006/relationships" r:id="R7b09908df8f34830"/>
   </p:notesMasterIdLst>
   <p:sldIdLst>
-    <p:sldId xmlns:r="http://schemas.openxmlformats.org/officeDocument/2006/relationships" id="256" r:id="R8a3a0580d4b848ea"/>
-    <p:sldId xmlns:r="http://schemas.openxmlformats.org/officeDocument/2006/relationships" id="257" r:id="Ra497248ff59f455c"/>
-    <p:sldId xmlns:r="http://schemas.openxmlformats.org/officeDocument/2006/relationships" id="258" r:id="Rb5f95fd481664150"/>
-    <p:sldId xmlns:r="http://schemas.openxmlformats.org/officeDocument/2006/relationships" id="259" r:id="R67219f5163004513"/>
-    <p:sldId xmlns:r="http://schemas.openxmlformats.org/officeDocument/2006/relationships" id="260" r:id="R686e95bdb61e4472"/>
-    <p:sldId xmlns:r="http://schemas.openxmlformats.org/officeDocument/2006/relationships" id="261" r:id="R5e16a2a7cb5b431c"/>
-    <p:sldId xmlns:r="http://schemas.openxmlformats.org/officeDocument/2006/relationships" id="262" r:id="R01c225de6eef4d92"/>
-    <p:sldId xmlns:r="http://schemas.openxmlformats.org/officeDocument/2006/relationships" id="263" r:id="Rb19e4b6e25d14c53"/>
-    <p:sldId xmlns:r="http://schemas.openxmlformats.org/officeDocument/2006/relationships" id="264" r:id="R9c260ebe78284356"/>
-    <p:sldId xmlns:r="http://schemas.openxmlformats.org/officeDocument/2006/relationships" id="265" r:id="R30537506367348a4"/>
-    <p:sldId xmlns:r="http://schemas.openxmlformats.org/officeDocument/2006/relationships" id="266" r:id="R711da4120844460c"/>
-    <p:sldId xmlns:r="http://schemas.openxmlformats.org/officeDocument/2006/relationships" id="267" r:id="R91104582e36840db"/>
-    <p:sldId xmlns:r="http://schemas.openxmlformats.org/officeDocument/2006/relationships" id="268" r:id="R886d0807d2f74bfa"/>
-    <p:sldId xmlns:r="http://schemas.openxmlformats.org/officeDocument/2006/relationships" id="269" r:id="Ra3025c1c2b6c4745"/>
-    <p:sldId xmlns:r="http://schemas.openxmlformats.org/officeDocument/2006/relationships" id="270" r:id="R06b5fd88a0e74b01"/>
-    <p:sldId xmlns:r="http://schemas.openxmlformats.org/officeDocument/2006/relationships" id="271" r:id="Rcf430da10ca741f6"/>
-    <p:sldId xmlns:r="http://schemas.openxmlformats.org/officeDocument/2006/relationships" id="272" r:id="R537582a54410420c"/>
-    <p:sldId xmlns:r="http://schemas.openxmlformats.org/officeDocument/2006/relationships" id="273" r:id="R696e9d98963d48bc"/>
+    <p:sldId xmlns:r="http://schemas.openxmlformats.org/officeDocument/2006/relationships" id="256" r:id="R821d96d8c8fa4e0b"/>
+    <p:sldId xmlns:r="http://schemas.openxmlformats.org/officeDocument/2006/relationships" id="257" r:id="Rf477984920f94b07"/>
+    <p:sldId xmlns:r="http://schemas.openxmlformats.org/officeDocument/2006/relationships" id="258" r:id="R879b67dab9b6471d"/>
+    <p:sldId xmlns:r="http://schemas.openxmlformats.org/officeDocument/2006/relationships" id="259" r:id="Rccdeac98821d4c7d"/>
+    <p:sldId xmlns:r="http://schemas.openxmlformats.org/officeDocument/2006/relationships" id="260" r:id="R813e0f8a6aee4687"/>
+    <p:sldId xmlns:r="http://schemas.openxmlformats.org/officeDocument/2006/relationships" id="261" r:id="R8045b94086774f6c"/>
+    <p:sldId xmlns:r="http://schemas.openxmlformats.org/officeDocument/2006/relationships" id="262" r:id="Ra74a206b55444777"/>
+    <p:sldId xmlns:r="http://schemas.openxmlformats.org/officeDocument/2006/relationships" id="263" r:id="R7d90d6d2ea504719"/>
+    <p:sldId xmlns:r="http://schemas.openxmlformats.org/officeDocument/2006/relationships" id="264" r:id="Rb5af09dccf9a46b8"/>
+    <p:sldId xmlns:r="http://schemas.openxmlformats.org/officeDocument/2006/relationships" id="265" r:id="Rba1368b606d94525"/>
+    <p:sldId xmlns:r="http://schemas.openxmlformats.org/officeDocument/2006/relationships" id="266" r:id="R822bea25d531400d"/>
+    <p:sldId xmlns:r="http://schemas.openxmlformats.org/officeDocument/2006/relationships" id="267" r:id="R47814ded37744868"/>
+    <p:sldId xmlns:r="http://schemas.openxmlformats.org/officeDocument/2006/relationships" id="268" r:id="R0c363c52eb3443f2"/>
+    <p:sldId xmlns:r="http://schemas.openxmlformats.org/officeDocument/2006/relationships" id="269" r:id="R2b3f95746c4d4ad0"/>
+    <p:sldId xmlns:r="http://schemas.openxmlformats.org/officeDocument/2006/relationships" id="270" r:id="R9fe16a7aa7d441cd"/>
+    <p:sldId xmlns:r="http://schemas.openxmlformats.org/officeDocument/2006/relationships" id="271" r:id="Rdd5a549140484d09"/>
+    <p:sldId xmlns:r="http://schemas.openxmlformats.org/officeDocument/2006/relationships" id="272" r:id="R3f64c0a5bafc4d1b"/>
+    <p:sldId xmlns:r="http://schemas.openxmlformats.org/officeDocument/2006/relationships" id="273" r:id="Rdccd847372804244"/>
   </p:sldIdLst>
   <p:sldSz cx="12192000" cy="6858000"/>
   <p:notesSz cx="6858000" cy="9144000"/>
@@ -459,7 +459,7 @@
           <a:lstStyle xmlns:a="http://schemas.openxmlformats.org/drawingml/2006/main"/>
           <a:p xmlns:a="http://schemas.openxmlformats.org/drawingml/2006/main">
             <a:r>
-              <a:t>Revise360 original lesson content. Teaching examples support OCR J277 Topic 2.5. The low-level instruction model is explanatory enrichment, not an additional required instruction set.</a:t>
+              <a:t>Revise360 original lesson content. Teaching examples support OCR J277 Topic 2.5. Scope: OCR J277 specification v3.1, May 2026, printed page 21, sections 2.5.1 and 2.5.2. https://www.ocr.org.uk/images/558027-specification-gcse-computer-science-j277.pdf</a:t>
             </a:r>
           </a:p>
         </p:txBody>
@@ -529,7 +529,7 @@
           <a:lstStyle xmlns:a="http://schemas.openxmlformats.org/drawingml/2006/main"/>
           <a:p xmlns:a="http://schemas.openxmlformats.org/drawingml/2006/main">
             <a:r>
-              <a:t>Revise360 original lesson content. Teaching examples support OCR J277 Topic 2.5. The low-level instruction model is explanatory enrichment, not an additional required instruction set.</a:t>
+              <a:t>Revise360 original lesson content. Teaching examples support OCR J277 Topic 2.5. Scope: OCR J277 specification v3.1, May 2026, printed page 21, sections 2.5.1 and 2.5.2. https://www.ocr.org.uk/images/558027-specification-gcse-computer-science-j277.pdf</a:t>
             </a:r>
           </a:p>
         </p:txBody>
@@ -599,7 +599,7 @@
           <a:lstStyle xmlns:a="http://schemas.openxmlformats.org/drawingml/2006/main"/>
           <a:p xmlns:a="http://schemas.openxmlformats.org/drawingml/2006/main">
             <a:r>
-              <a:t>Revise360 original lesson content. Teaching examples support OCR J277 Topic 2.5. The low-level instruction model is explanatory enrichment, not an additional required instruction set.</a:t>
+              <a:t>Revise360 original lesson content. Teaching examples support OCR J277 Topic 2.5. Scope: OCR J277 specification v3.1, May 2026, printed page 21, sections 2.5.1 and 2.5.2. https://www.ocr.org.uk/images/558027-specification-gcse-computer-science-j277.pdf</a:t>
             </a:r>
           </a:p>
         </p:txBody>
@@ -669,7 +669,7 @@
           <a:lstStyle xmlns:a="http://schemas.openxmlformats.org/drawingml/2006/main"/>
           <a:p xmlns:a="http://schemas.openxmlformats.org/drawingml/2006/main">
             <a:r>
-              <a:t>Revise360 original lesson content. Teaching examples support OCR J277 Topic 2.5. The low-level instruction model is explanatory enrichment, not an additional required instruction set.</a:t>
+              <a:t>Revise360 original lesson content. Teaching examples support OCR J277 Topic 2.5. Scope: OCR J277 specification v3.1, May 2026, printed page 21, sections 2.5.1 and 2.5.2. https://www.ocr.org.uk/images/558027-specification-gcse-computer-science-j277.pdf</a:t>
             </a:r>
           </a:p>
         </p:txBody>
@@ -739,7 +739,7 @@
           <a:lstStyle xmlns:a="http://schemas.openxmlformats.org/drawingml/2006/main"/>
           <a:p xmlns:a="http://schemas.openxmlformats.org/drawingml/2006/main">
             <a:r>
-              <a:t>Revise360 original lesson content. Teaching examples support OCR J277 Topic 2.5. The low-level instruction model is explanatory enrichment, not an additional required instruction set.</a:t>
+              <a:t>Revise360 original lesson content. Teaching examples support OCR J277 Topic 2.5. Scope: OCR J277 specification v3.1, May 2026, printed page 21, sections 2.5.1 and 2.5.2. https://www.ocr.org.uk/images/558027-specification-gcse-computer-science-j277.pdf</a:t>
             </a:r>
           </a:p>
         </p:txBody>
@@ -809,7 +809,7 @@
           <a:lstStyle xmlns:a="http://schemas.openxmlformats.org/drawingml/2006/main"/>
           <a:p xmlns:a="http://schemas.openxmlformats.org/drawingml/2006/main">
             <a:r>
-              <a:t>Revise360 original lesson content. Teaching examples support OCR J277 Topic 2.5. The low-level instruction model is explanatory enrichment, not an additional required instruction set.</a:t>
+              <a:t>Revise360 original lesson content. Teaching examples support OCR J277 Topic 2.5. Scope: OCR J277 specification v3.1, May 2026, printed page 21, sections 2.5.1 and 2.5.2. https://www.ocr.org.uk/images/558027-specification-gcse-computer-science-j277.pdf</a:t>
             </a:r>
           </a:p>
         </p:txBody>
@@ -879,7 +879,7 @@
           <a:lstStyle xmlns:a="http://schemas.openxmlformats.org/drawingml/2006/main"/>
           <a:p xmlns:a="http://schemas.openxmlformats.org/drawingml/2006/main">
             <a:r>
-              <a:t>Revise360 original lesson content. Teaching examples support OCR J277 Topic 2.5. The low-level instruction model is explanatory enrichment, not an additional required instruction set.</a:t>
+              <a:t>Revise360 original lesson content. Teaching examples support OCR J277 Topic 2.5. Scope: OCR J277 specification v3.1, May 2026, printed page 21, sections 2.5.1 and 2.5.2. https://www.ocr.org.uk/images/558027-specification-gcse-computer-science-j277.pdf</a:t>
             </a:r>
           </a:p>
         </p:txBody>
@@ -949,7 +949,7 @@
           <a:lstStyle xmlns:a="http://schemas.openxmlformats.org/drawingml/2006/main"/>
           <a:p xmlns:a="http://schemas.openxmlformats.org/drawingml/2006/main">
             <a:r>
-              <a:t>Revise360 original lesson content. Teaching examples support OCR J277 Topic 2.5. The low-level instruction model is explanatory enrichment, not an additional required instruction set.</a:t>
+              <a:t>Revise360 original lesson content. Teaching examples support OCR J277 Topic 2.5. Scope: OCR J277 specification v3.1, May 2026, printed page 21, sections 2.5.1 and 2.5.2. https://www.ocr.org.uk/images/558027-specification-gcse-computer-science-j277.pdf</a:t>
             </a:r>
           </a:p>
         </p:txBody>
@@ -1019,7 +1019,7 @@
           <a:lstStyle xmlns:a="http://schemas.openxmlformats.org/drawingml/2006/main"/>
           <a:p xmlns:a="http://schemas.openxmlformats.org/drawingml/2006/main">
             <a:r>
-              <a:t>Revise360 original lesson content. Teaching examples support OCR J277 Topic 2.5. The low-level instruction model is explanatory enrichment, not an additional required instruction set.</a:t>
+              <a:t>Revise360 original lesson content. Teaching examples support OCR J277 Topic 2.5. Scope: OCR J277 specification v3.1, May 2026, printed page 21, sections 2.5.1 and 2.5.2. https://www.ocr.org.uk/images/558027-specification-gcse-computer-science-j277.pdf</a:t>
             </a:r>
           </a:p>
         </p:txBody>
@@ -1089,7 +1089,7 @@
           <a:lstStyle xmlns:a="http://schemas.openxmlformats.org/drawingml/2006/main"/>
           <a:p xmlns:a="http://schemas.openxmlformats.org/drawingml/2006/main">
             <a:r>
-              <a:t>Revise360 original lesson content. Teaching examples support OCR J277 Topic 2.5. The low-level instruction model is explanatory enrichment, not an additional required instruction set.</a:t>
+              <a:t>Revise360 original lesson content. Teaching examples support OCR J277 Topic 2.5. Scope: OCR J277 specification v3.1, May 2026, printed page 21, sections 2.5.1 and 2.5.2. https://www.ocr.org.uk/images/558027-specification-gcse-computer-science-j277.pdf</a:t>
             </a:r>
           </a:p>
         </p:txBody>
@@ -1159,7 +1159,7 @@
           <a:lstStyle xmlns:a="http://schemas.openxmlformats.org/drawingml/2006/main"/>
           <a:p xmlns:a="http://schemas.openxmlformats.org/drawingml/2006/main">
             <a:r>
-              <a:t>Revise360 original lesson content. Teaching examples support OCR J277 Topic 2.5. The low-level instruction model is explanatory enrichment, not an additional required instruction set.</a:t>
+              <a:t>Revise360 original lesson content. Teaching examples support OCR J277 Topic 2.5. Scope: OCR J277 specification v3.1, May 2026, printed page 21, sections 2.5.1 and 2.5.2. https://www.ocr.org.uk/images/558027-specification-gcse-computer-science-j277.pdf</a:t>
             </a:r>
           </a:p>
         </p:txBody>
@@ -1229,7 +1229,7 @@
           <a:lstStyle xmlns:a="http://schemas.openxmlformats.org/drawingml/2006/main"/>
           <a:p xmlns:a="http://schemas.openxmlformats.org/drawingml/2006/main">
             <a:r>
-              <a:t>Revise360 original lesson content. Teaching examples support OCR J277 Topic 2.5. The low-level instruction model is explanatory enrichment, not an additional required instruction set.</a:t>
+              <a:t>Revise360 original lesson content. Teaching examples support OCR J277 Topic 2.5. Scope: OCR J277 specification v3.1, May 2026, printed page 21, sections 2.5.1 and 2.5.2. https://www.ocr.org.uk/images/558027-specification-gcse-computer-science-j277.pdf</a:t>
             </a:r>
           </a:p>
         </p:txBody>
@@ -1299,7 +1299,7 @@
           <a:lstStyle xmlns:a="http://schemas.openxmlformats.org/drawingml/2006/main"/>
           <a:p xmlns:a="http://schemas.openxmlformats.org/drawingml/2006/main">
             <a:r>
-              <a:t>Revise360 original lesson content. Teaching examples support OCR J277 Topic 2.5. The low-level instruction model is explanatory enrichment, not an additional required instruction set.</a:t>
+              <a:t>Revise360 original lesson content. Teaching examples support OCR J277 Topic 2.5. Scope: OCR J277 specification v3.1, May 2026, printed page 21, sections 2.5.1 and 2.5.2. https://www.ocr.org.uk/images/558027-specification-gcse-computer-science-j277.pdf</a:t>
             </a:r>
           </a:p>
         </p:txBody>
@@ -1369,7 +1369,7 @@
           <a:lstStyle xmlns:a="http://schemas.openxmlformats.org/drawingml/2006/main"/>
           <a:p xmlns:a="http://schemas.openxmlformats.org/drawingml/2006/main">
             <a:r>
-              <a:t>Revise360 original lesson content. Teaching examples support OCR J277 Topic 2.5. The low-level instruction model is explanatory enrichment, not an additional required instruction set.</a:t>
+              <a:t>Revise360 original lesson content. Teaching examples support OCR J277 Topic 2.5. Scope: OCR J277 specification v3.1, May 2026, printed page 21, sections 2.5.1 and 2.5.2. https://www.ocr.org.uk/images/558027-specification-gcse-computer-science-j277.pdf</a:t>
             </a:r>
           </a:p>
         </p:txBody>
@@ -1439,7 +1439,7 @@
           <a:lstStyle xmlns:a="http://schemas.openxmlformats.org/drawingml/2006/main"/>
           <a:p xmlns:a="http://schemas.openxmlformats.org/drawingml/2006/main">
             <a:r>
-              <a:t>Revise360 original lesson content. Teaching examples support OCR J277 Topic 2.5. The low-level instruction model is explanatory enrichment, not an additional required instruction set.</a:t>
+              <a:t>Revise360 original lesson content. Teaching examples support OCR J277 Topic 2.5. Scope: OCR J277 specification v3.1, May 2026, printed page 21, sections 2.5.1 and 2.5.2. https://www.ocr.org.uk/images/558027-specification-gcse-computer-science-j277.pdf</a:t>
             </a:r>
           </a:p>
         </p:txBody>
@@ -1509,7 +1509,7 @@
           <a:lstStyle xmlns:a="http://schemas.openxmlformats.org/drawingml/2006/main"/>
           <a:p xmlns:a="http://schemas.openxmlformats.org/drawingml/2006/main">
             <a:r>
-              <a:t>Revise360 original lesson content. Teaching examples support OCR J277 Topic 2.5. The low-level instruction model is explanatory enrichment, not an additional required instruction set.</a:t>
+              <a:t>Revise360 original lesson content. Teaching examples support OCR J277 Topic 2.5. Scope: OCR J277 specification v3.1, May 2026, printed page 21, sections 2.5.1 and 2.5.2. https://www.ocr.org.uk/images/558027-specification-gcse-computer-science-j277.pdf</a:t>
             </a:r>
           </a:p>
         </p:txBody>
@@ -1579,7 +1579,7 @@
           <a:lstStyle xmlns:a="http://schemas.openxmlformats.org/drawingml/2006/main"/>
           <a:p xmlns:a="http://schemas.openxmlformats.org/drawingml/2006/main">
             <a:r>
-              <a:t>Revise360 original lesson content. Teaching examples support OCR J277 Topic 2.5. The low-level instruction model is explanatory enrichment, not an additional required instruction set.</a:t>
+              <a:t>Revise360 original lesson content. Teaching examples support OCR J277 Topic 2.5. Scope: OCR J277 specification v3.1, May 2026, printed page 21, sections 2.5.1 and 2.5.2. https://www.ocr.org.uk/images/558027-specification-gcse-computer-science-j277.pdf</a:t>
             </a:r>
           </a:p>
         </p:txBody>
@@ -1649,7 +1649,7 @@
           <a:lstStyle xmlns:a="http://schemas.openxmlformats.org/drawingml/2006/main"/>
           <a:p xmlns:a="http://schemas.openxmlformats.org/drawingml/2006/main">
             <a:r>
-              <a:t>Revise360 original lesson content. Teaching examples support OCR J277 Topic 2.5. The low-level instruction model is explanatory enrichment, not an additional required instruction set.</a:t>
+              <a:t>Revise360 original lesson content. Teaching examples support OCR J277 Topic 2.5. Scope: OCR J277 specification v3.1, May 2026, printed page 21, sections 2.5.1 and 2.5.2. https://www.ocr.org.uk/images/558027-specification-gcse-computer-science-j277.pdf</a:t>
             </a:r>
           </a:p>
         </p:txBody>
@@ -1717,7 +1717,7 @@
   </p:cSld>
   <p:clrMap bg1="lt1" tx1="dk1" bg2="lt2" tx2="dk2" accent1="accent1" accent2="accent2" accent3="accent3" accent4="accent4" accent5="accent5" accent6="accent6" hlink="hlink" folHlink="folHlink"/>
   <p:sldLayoutIdLst>
-    <p:sldLayoutId xmlns:r="http://schemas.openxmlformats.org/officeDocument/2006/relationships" id="2147483649" r:id="Ra25b3fb7ee524b53"/>
+    <p:sldLayoutId xmlns:r="http://schemas.openxmlformats.org/officeDocument/2006/relationships" id="2147483649" r:id="R179cec44b5564989"/>
   </p:sldLayoutIdLst>
   <p:txStyles>
     <p:titleStyle>
@@ -2418,7 +2418,7 @@
           <p:nvPr/>
         </p:nvPicPr>
         <p:blipFill>
-          <a:blip xmlns:r="http://schemas.openxmlformats.org/officeDocument/2006/relationships" xmlns:a="http://schemas.openxmlformats.org/drawingml/2006/main" r:embed="Rcb6b5693f269417a"/>
+          <a:blip xmlns:r="http://schemas.openxmlformats.org/officeDocument/2006/relationships" xmlns:a="http://schemas.openxmlformats.org/drawingml/2006/main" r:embed="Rba2c603a2de5443b"/>
           <a:stretch xmlns:a="http://schemas.openxmlformats.org/drawingml/2006/main"/>
         </p:blipFill>
         <p:spPr>
@@ -2672,7 +2672,7 @@
           <p:nvPr/>
         </p:nvPicPr>
         <p:blipFill>
-          <a:blip xmlns:r="http://schemas.openxmlformats.org/officeDocument/2006/relationships" xmlns:a="http://schemas.openxmlformats.org/drawingml/2006/main" r:embed="Ra6f9a7e7f43f4aca"/>
+          <a:blip xmlns:r="http://schemas.openxmlformats.org/officeDocument/2006/relationships" xmlns:a="http://schemas.openxmlformats.org/drawingml/2006/main" r:embed="Raa956463f16c48c9"/>
           <a:stretch xmlns:a="http://schemas.openxmlformats.org/drawingml/2006/main"/>
         </p:blipFill>
         <p:spPr>
@@ -2869,7 +2869,7 @@
           <p:nvPr/>
         </p:nvPicPr>
         <p:blipFill>
-          <a:blip xmlns:r="http://schemas.openxmlformats.org/officeDocument/2006/relationships" xmlns:a="http://schemas.openxmlformats.org/drawingml/2006/main" r:embed="R1ea8e22a471b406f"/>
+          <a:blip xmlns:r="http://schemas.openxmlformats.org/officeDocument/2006/relationships" xmlns:a="http://schemas.openxmlformats.org/drawingml/2006/main" r:embed="R135a1abb4ab44ae1"/>
           <a:stretch xmlns:a="http://schemas.openxmlformats.org/drawingml/2006/main"/>
         </p:blipFill>
         <p:spPr>
@@ -3414,7 +3414,7 @@
           <p:nvPr/>
         </p:nvPicPr>
         <p:blipFill>
-          <a:blip xmlns:r="http://schemas.openxmlformats.org/officeDocument/2006/relationships" xmlns:a="http://schemas.openxmlformats.org/drawingml/2006/main" r:embed="R19ab0a56251d46d8"/>
+          <a:blip xmlns:r="http://schemas.openxmlformats.org/officeDocument/2006/relationships" xmlns:a="http://schemas.openxmlformats.org/drawingml/2006/main" r:embed="R294a1c6ad1c94e66"/>
           <a:stretch xmlns:a="http://schemas.openxmlformats.org/drawingml/2006/main"/>
         </p:blipFill>
         <p:spPr>
@@ -4075,7 +4075,7 @@
           <p:nvPr/>
         </p:nvPicPr>
         <p:blipFill>
-          <a:blip xmlns:r="http://schemas.openxmlformats.org/officeDocument/2006/relationships" xmlns:a="http://schemas.openxmlformats.org/drawingml/2006/main" r:embed="R9c857bc005074cbb"/>
+          <a:blip xmlns:r="http://schemas.openxmlformats.org/officeDocument/2006/relationships" xmlns:a="http://schemas.openxmlformats.org/drawingml/2006/main" r:embed="R6fc1dd7b395e46b3"/>
           <a:stretch xmlns:a="http://schemas.openxmlformats.org/drawingml/2006/main"/>
         </p:blipFill>
         <p:spPr>
@@ -4257,7 +4257,7 @@
                 <a:ea typeface="DejaVu Sans"/>
                 <a:cs typeface="DejaVu Sans"/>
               </a:rPr>
-              <a:t>4  Assembly language</a:t>
+              <a:t>4  The need for translation</a:t>
             </a:r>
           </a:p>
         </p:txBody>
@@ -4315,7 +4315,7 @@
                 <a:ea typeface="DejaVu Sans"/>
                 <a:cs typeface="DejaVu Sans"/>
               </a:rPr>
-              <a:t>Assembly instructions remain closely tied to a processor instruction set, even though mnemonics are readable.</a:t>
+              <a:t>A CPU executes machine code. A translator processes high-level source so its instructions can be executed.</a:t>
             </a:r>
           </a:p>
         </p:txBody>
@@ -4431,7 +4431,7 @@
                 <a:ea typeface="DejaVu Sans"/>
                 <a:cs typeface="DejaVu Sans"/>
               </a:rPr>
-              <a:t>A compatible Python runtime and any required libraries must be available.</a:t>
+              <a:t>A compatible Python interpreter must be available to translate and execute the source.</a:t>
             </a:r>
           </a:p>
         </p:txBody>
@@ -4736,7 +4736,7 @@
           <p:nvPr/>
         </p:nvPicPr>
         <p:blipFill>
-          <a:blip xmlns:r="http://schemas.openxmlformats.org/officeDocument/2006/relationships" xmlns:a="http://schemas.openxmlformats.org/drawingml/2006/main" r:embed="R18c288f45aad4874"/>
+          <a:blip xmlns:r="http://schemas.openxmlformats.org/officeDocument/2006/relationships" xmlns:a="http://schemas.openxmlformats.org/drawingml/2006/main" r:embed="R43c6fa8bc0d749b4"/>
           <a:stretch xmlns:a="http://schemas.openxmlformats.org/drawingml/2006/main"/>
         </p:blipFill>
         <p:spPr>
@@ -5024,7 +5024,7 @@
                 <a:ea typeface="DejaVu Sans"/>
                 <a:cs typeface="DejaVu Sans"/>
               </a:rPr>
-              <a:t>High-level for a changing school quiz: Easier to read and maintain. Low-level for a hardware-specific routine: Direct control of processor operations. Check before moving high-level source to another system: A compatible runtime and dependencies are available</a:t>
+              <a:t>High-level for a changing school quiz: Easier to read and maintain. Low-level for a hardware-specific routine: Direct control of processor operations. Check before moving high-level source to another system: A compatible translator is available</a:t>
             </a:r>
           </a:p>
         </p:txBody>
@@ -5793,7 +5793,7 @@
           <p:nvPr/>
         </p:nvPicPr>
         <p:blipFill>
-          <a:blip xmlns:r="http://schemas.openxmlformats.org/officeDocument/2006/relationships" xmlns:a="http://schemas.openxmlformats.org/drawingml/2006/main" r:embed="Rdb95bfa3e9f34e00"/>
+          <a:blip xmlns:r="http://schemas.openxmlformats.org/officeDocument/2006/relationships" xmlns:a="http://schemas.openxmlformats.org/drawingml/2006/main" r:embed="R2ad101887e6246d0"/>
           <a:stretch xmlns:a="http://schemas.openxmlformats.org/drawingml/2006/main"/>
         </p:blipFill>
         <p:spPr>
@@ -6149,7 +6149,7 @@
                 <a:ea typeface="DejaVu Sans"/>
                 <a:cs typeface="DejaVu Sans"/>
               </a:rPr>
-              <a:t>State one difference between assembly and machine code. [2]</a:t>
+              <a:t>Explain one difference between high-level and low-level languages. [2]</a:t>
             </a:r>
           </a:p>
         </p:txBody>
@@ -6338,7 +6338,7 @@
           <p:nvPr/>
         </p:nvPicPr>
         <p:blipFill>
-          <a:blip xmlns:r="http://schemas.openxmlformats.org/officeDocument/2006/relationships" xmlns:a="http://schemas.openxmlformats.org/drawingml/2006/main" r:embed="R16188a25d14d437d"/>
+          <a:blip xmlns:r="http://schemas.openxmlformats.org/officeDocument/2006/relationships" xmlns:a="http://schemas.openxmlformats.org/drawingml/2006/main" r:embed="Ra9263708806c4b2e"/>
           <a:stretch xmlns:a="http://schemas.openxmlformats.org/drawingml/2006/main"/>
         </p:blipFill>
         <p:spPr>
@@ -6825,7 +6825,7 @@
           <p:nvPr/>
         </p:nvPicPr>
         <p:blipFill>
-          <a:blip xmlns:r="http://schemas.openxmlformats.org/officeDocument/2006/relationships" xmlns:a="http://schemas.openxmlformats.org/drawingml/2006/main" r:embed="R3c3b30c28030418b"/>
+          <a:blip xmlns:r="http://schemas.openxmlformats.org/officeDocument/2006/relationships" xmlns:a="http://schemas.openxmlformats.org/drawingml/2006/main" r:embed="Rcccc04f857d24b11"/>
           <a:stretch xmlns:a="http://schemas.openxmlformats.org/drawingml/2006/main"/>
         </p:blipFill>
         <p:spPr>
@@ -7065,7 +7065,7 @@
                 <a:ea typeface="DejaVu Sans"/>
                 <a:cs typeface="DejaVu Sans"/>
               </a:rPr>
-              <a:t>b  Assembly uses readable mnemonics for instructions. Machine code represents processor instructions in binary.</a:t>
+              <a:t>b  High-level languages hide many hardware details. Low-level languages closely reflect processor instructions.</a:t>
             </a:r>
           </a:p>
         </p:txBody>
@@ -7254,7 +7254,7 @@
           <p:nvPr/>
         </p:nvPicPr>
         <p:blipFill>
-          <a:blip xmlns:r="http://schemas.openxmlformats.org/officeDocument/2006/relationships" xmlns:a="http://schemas.openxmlformats.org/drawingml/2006/main" r:embed="R21df6cc0d8974fb1"/>
+          <a:blip xmlns:r="http://schemas.openxmlformats.org/officeDocument/2006/relationships" xmlns:a="http://schemas.openxmlformats.org/drawingml/2006/main" r:embed="R6ea5a9a8f1cc4fcc"/>
           <a:stretch xmlns:a="http://schemas.openxmlformats.org/drawingml/2006/main"/>
         </p:blipFill>
         <p:spPr>
@@ -7915,7 +7915,7 @@
           <p:nvPr/>
         </p:nvPicPr>
         <p:blipFill>
-          <a:blip xmlns:r="http://schemas.openxmlformats.org/officeDocument/2006/relationships" xmlns:a="http://schemas.openxmlformats.org/drawingml/2006/main" r:embed="R15c2f085496a41ab"/>
+          <a:blip xmlns:r="http://schemas.openxmlformats.org/officeDocument/2006/relationships" xmlns:a="http://schemas.openxmlformats.org/drawingml/2006/main" r:embed="R39242f5e93b744c0"/>
           <a:stretch xmlns:a="http://schemas.openxmlformats.org/drawingml/2006/main"/>
         </p:blipFill>
         <p:spPr>
@@ -8271,7 +8271,7 @@
                 <a:ea typeface="DejaVu Sans"/>
                 <a:cs typeface="DejaVu Sans"/>
               </a:rPr>
-              <a:t>Distinguish source code, assembly and machine code.</a:t>
+              <a:t>Explain why high-level source needs translation.</a:t>
             </a:r>
           </a:p>
         </p:txBody>
@@ -8692,7 +8692,7 @@
           <p:nvPr/>
         </p:nvPicPr>
         <p:blipFill>
-          <a:blip xmlns:r="http://schemas.openxmlformats.org/officeDocument/2006/relationships" xmlns:a="http://schemas.openxmlformats.org/drawingml/2006/main" r:embed="R0d76eabc83414433"/>
+          <a:blip xmlns:r="http://schemas.openxmlformats.org/officeDocument/2006/relationships" xmlns:a="http://schemas.openxmlformats.org/drawingml/2006/main" r:embed="Rb71f525c56ee4532"/>
           <a:stretch xmlns:a="http://schemas.openxmlformats.org/drawingml/2006/main"/>
         </p:blipFill>
         <p:spPr>
@@ -8990,7 +8990,7 @@
                 <a:ea typeface="DejaVu Sans"/>
                 <a:cs typeface="DejaVu Sans"/>
               </a:rPr>
-              <a:t>Distinguish source code, assembly and machine code.</a:t>
+              <a:t>Explain why high-level source needs translation.</a:t>
             </a:r>
           </a:p>
         </p:txBody>
@@ -9411,7 +9411,7 @@
           <p:nvPr/>
         </p:nvPicPr>
         <p:blipFill>
-          <a:blip xmlns:r="http://schemas.openxmlformats.org/officeDocument/2006/relationships" xmlns:a="http://schemas.openxmlformats.org/drawingml/2006/main" r:embed="R16128c5e47684010"/>
+          <a:blip xmlns:r="http://schemas.openxmlformats.org/officeDocument/2006/relationships" xmlns:a="http://schemas.openxmlformats.org/drawingml/2006/main" r:embed="R21d41b43fa994753"/>
           <a:stretch xmlns:a="http://schemas.openxmlformats.org/drawingml/2006/main"/>
         </p:blipFill>
         <p:spPr>
@@ -9724,7 +9724,7 @@
           <p:nvPr/>
         </p:nvPicPr>
         <p:blipFill>
-          <a:blip xmlns:r="http://schemas.openxmlformats.org/officeDocument/2006/relationships" xmlns:a="http://schemas.openxmlformats.org/drawingml/2006/main" r:embed="R61315fbb712944d6"/>
+          <a:blip xmlns:r="http://schemas.openxmlformats.org/officeDocument/2006/relationships" xmlns:a="http://schemas.openxmlformats.org/drawingml/2006/main" r:embed="Re9dc502083d74196"/>
           <a:stretch xmlns:a="http://schemas.openxmlformats.org/drawingml/2006/main"/>
         </p:blipFill>
         <p:spPr>
@@ -10211,7 +10211,7 @@
           <p:nvPr/>
         </p:nvPicPr>
         <p:blipFill>
-          <a:blip xmlns:r="http://schemas.openxmlformats.org/officeDocument/2006/relationships" xmlns:a="http://schemas.openxmlformats.org/drawingml/2006/main" r:embed="Rf9f0c98e179d4442"/>
+          <a:blip xmlns:r="http://schemas.openxmlformats.org/officeDocument/2006/relationships" xmlns:a="http://schemas.openxmlformats.org/drawingml/2006/main" r:embed="R4b442ca3173c498a"/>
           <a:stretch xmlns:a="http://schemas.openxmlformats.org/drawingml/2006/main"/>
         </p:blipFill>
         <p:spPr>
@@ -10698,7 +10698,7 @@
           <p:nvPr/>
         </p:nvPicPr>
         <p:blipFill>
-          <a:blip xmlns:r="http://schemas.openxmlformats.org/officeDocument/2006/relationships" xmlns:a="http://schemas.openxmlformats.org/drawingml/2006/main" r:embed="R46e5f48a5f614e72"/>
+          <a:blip xmlns:r="http://schemas.openxmlformats.org/officeDocument/2006/relationships" xmlns:a="http://schemas.openxmlformats.org/drawingml/2006/main" r:embed="R2ca6fc20c4904c3f"/>
           <a:stretch xmlns:a="http://schemas.openxmlformats.org/drawingml/2006/main"/>
         </p:blipFill>
         <p:spPr>
@@ -11185,7 +11185,7 @@
           <p:nvPr/>
         </p:nvPicPr>
         <p:blipFill>
-          <a:blip xmlns:r="http://schemas.openxmlformats.org/officeDocument/2006/relationships" xmlns:a="http://schemas.openxmlformats.org/drawingml/2006/main" r:embed="Rbc08a5f2d9104ac2"/>
+          <a:blip xmlns:r="http://schemas.openxmlformats.org/officeDocument/2006/relationships" xmlns:a="http://schemas.openxmlformats.org/drawingml/2006/main" r:embed="R9042a50881aa4f30"/>
           <a:stretch xmlns:a="http://schemas.openxmlformats.org/drawingml/2006/main"/>
         </p:blipFill>
         <p:spPr>
@@ -11904,7 +11904,7 @@
           <p:nvPr/>
         </p:nvPicPr>
         <p:blipFill>
-          <a:blip xmlns:r="http://schemas.openxmlformats.org/officeDocument/2006/relationships" xmlns:a="http://schemas.openxmlformats.org/drawingml/2006/main" r:embed="R2a64dd919091424c"/>
+          <a:blip xmlns:r="http://schemas.openxmlformats.org/officeDocument/2006/relationships" xmlns:a="http://schemas.openxmlformats.org/drawingml/2006/main" r:embed="R61d35bf1440a4f88"/>
           <a:stretch xmlns:a="http://schemas.openxmlformats.org/drawingml/2006/main"/>
         </p:blipFill>
         <p:spPr>
@@ -12275,7 +12275,7 @@
           <p:nvPr/>
         </p:nvPicPr>
         <p:blipFill>
-          <a:blip xmlns:r="http://schemas.openxmlformats.org/officeDocument/2006/relationships" xmlns:a="http://schemas.openxmlformats.org/drawingml/2006/main" r:embed="R7d2525dcffda4c43"/>
+          <a:blip xmlns:r="http://schemas.openxmlformats.org/officeDocument/2006/relationships" xmlns:a="http://schemas.openxmlformats.org/drawingml/2006/main" r:embed="R93940dc91ef44c6a"/>
           <a:stretch xmlns:a="http://schemas.openxmlformats.org/drawingml/2006/main"/>
         </p:blipFill>
         <p:spPr>

</xml_diff>